<commit_message>
Update ShopEZ presentation with actual screenshots and code implementation details
</commit_message>
<xml_diff>
--- a/MERN Phase Wise/Project Documentation/ShopEZ_Project_Presentation.pptx
+++ b/MERN Phase Wise/Project Documentation/ShopEZ_Project_Presentation.pptx
@@ -23,6 +23,10 @@
     <p:sldId id="268" r:id="rId19"/>
     <p:sldId id="269" r:id="rId20"/>
     <p:sldId id="270" r:id="rId21"/>
+    <p:sldId id="271" r:id="rId22"/>
+    <p:sldId id="272" r:id="rId23"/>
+    <p:sldId id="273" r:id="rId24"/>
+    <p:sldId id="274" r:id="rId25"/>
   </p:sldIdLst>
   <p:sldSz cy="5143500" cx="9144000"/>
   <p:notesSz cx="6858000" cy="9144000"/>
@@ -11822,42 +11826,158 @@
           <a:lstStyle/>
           <a:p>
             <a:pPr>
-              <a:defRPr sz="2400" b="1">
+              <a:defRPr sz="2200" b="1">
                 <a:solidFill>
                   <a:srgbClr val="C05C46"/>
                 </a:solidFill>
               </a:defRPr>
             </a:pPr>
             <a:r>
-              <a:t>Results: Cozy Catalog Home Page</a:t>
+              <a:t>Code Implementation: Async Wrapper (Backend)</a:t>
             </a:r>
           </a:p>
         </p:txBody>
       </p:sp>
-      <p:pic>
-        <p:nvPicPr>
-          <p:cNvPr id="5" name="Picture 4" descr="home.jpg"/>
-          <p:cNvPicPr>
-            <a:picLocks noChangeAspect="1"/>
-          </p:cNvPicPr>
+      <p:sp>
+        <p:nvSpPr>
+          <p:cNvPr id="5" name="TextBox 4"/>
+          <p:cNvSpPr txBox="1"/>
           <p:nvPr/>
-        </p:nvPicPr>
-        <p:blipFill>
-          <a:blip r:embed="rId2"/>
-          <a:stretch>
-            <a:fillRect/>
-          </a:stretch>
-        </p:blipFill>
+        </p:nvSpPr>
         <p:spPr>
           <a:xfrm>
-            <a:off x="914400" y="1371600"/>
-            <a:ext cx="7315200" cy="4114800"/>
+            <a:off x="457200" y="1097280"/>
+            <a:ext cx="8229600" cy="731520"/>
           </a:xfrm>
           <a:prstGeom prst="rect">
             <a:avLst/>
           </a:prstGeom>
+          <a:noFill/>
         </p:spPr>
-      </p:pic>
+        <p:txBody>
+          <a:bodyPr wrap="none">
+            <a:spAutoFit/>
+          </a:bodyPr>
+          <a:lstStyle/>
+          <a:p>
+            <a:pPr>
+              <a:defRPr sz="1200" i="1">
+                <a:solidFill>
+                  <a:srgbClr val="2D2724"/>
+                </a:solidFill>
+              </a:defRPr>
+            </a:pPr>
+            <a:r>
+              <a:t>Modular middleware ensuring error resiliency across all MongoDB queries</a:t>
+            </a:r>
+          </a:p>
+        </p:txBody>
+      </p:sp>
+      <p:sp>
+        <p:nvSpPr>
+          <p:cNvPr id="6" name="TextBox 5"/>
+          <p:cNvSpPr txBox="1"/>
+          <p:nvPr/>
+        </p:nvSpPr>
+        <p:spPr>
+          <a:xfrm>
+            <a:off x="457200" y="1828800"/>
+            <a:ext cx="8229600" cy="4114800"/>
+          </a:xfrm>
+          <a:prstGeom prst="rect">
+            <a:avLst/>
+          </a:prstGeom>
+          <a:noFill/>
+        </p:spPr>
+        <p:txBody>
+          <a:bodyPr wrap="square">
+            <a:spAutoFit/>
+          </a:bodyPr>
+          <a:lstStyle/>
+          <a:p>
+            <a:pPr>
+              <a:defRPr sz="1050">
+                <a:solidFill>
+                  <a:srgbClr val="2D2724"/>
+                </a:solidFill>
+                <a:latin typeface="Consolas"/>
+              </a:defRPr>
+            </a:pPr>
+            <a:r>
+              <a:t>// backend/utils/asyncHandler.js</a:t>
+            </a:r>
+            <a:br/>
+            <a:r>
+              <a:t>const asyncHandler = (fn) =&gt; (req, res, next) =&gt; {</a:t>
+            </a:r>
+            <a:br/>
+            <a:r>
+              <a:t>  Promise.resolve(fn(req, res, next)).catch(next);</a:t>
+            </a:r>
+            <a:br/>
+            <a:r>
+              <a:t>};</a:t>
+            </a:r>
+            <a:br/>
+            <a:br/>
+            <a:r>
+              <a:t>// Example Usage in route definition:</a:t>
+            </a:r>
+            <a:br/>
+            <a:r>
+              <a:t>router.get('/products', asyncHandler(getProducts));</a:t>
+            </a:r>
+            <a:br/>
+            <a:br/>
+            <a:r>
+              <a:t>// Benefits:</a:t>
+            </a:r>
+            <a:br/>
+            <a:r>
+              <a:t>- Eliminates massive repetitive try-catch blocks in route controllers.</a:t>
+            </a:r>
+            <a:br/>
+            <a:r>
+              <a:t>- Ensures all errors are forwarded to the server's global error handler middleware.</a:t>
+            </a:r>
+          </a:p>
+        </p:txBody>
+      </p:sp>
+      <p:sp>
+        <p:nvSpPr>
+          <p:cNvPr id="7" name="TextBox 6"/>
+          <p:cNvSpPr txBox="1"/>
+          <p:nvPr/>
+        </p:nvSpPr>
+        <p:spPr>
+          <a:xfrm>
+            <a:off x="457200" y="6217920"/>
+            <a:ext cx="8229600" cy="457200"/>
+          </a:xfrm>
+          <a:prstGeom prst="rect">
+            <a:avLst/>
+          </a:prstGeom>
+          <a:noFill/>
+        </p:spPr>
+        <p:txBody>
+          <a:bodyPr wrap="none">
+            <a:spAutoFit/>
+          </a:bodyPr>
+          <a:lstStyle/>
+          <a:p>
+            <a:pPr>
+              <a:defRPr sz="900" i="1">
+                <a:solidFill>
+                  <a:srgbClr val="72625B"/>
+                </a:solidFill>
+              </a:defRPr>
+            </a:pPr>
+            <a:r>
+              <a:t>Department of Computer Science and Engineering | Implementation Code</a:t>
+            </a:r>
+          </a:p>
+        </p:txBody>
+      </p:sp>
     </p:spTree>
   </p:cSld>
   <p:clrMapOvr>
@@ -11933,42 +12053,164 @@
           <a:lstStyle/>
           <a:p>
             <a:pPr>
-              <a:defRPr sz="2400" b="1">
+              <a:defRPr sz="2200" b="1">
                 <a:solidFill>
                   <a:srgbClr val="C05C46"/>
                 </a:solidFill>
               </a:defRPr>
             </a:pPr>
             <a:r>
-              <a:t>Results: Secure Login Screen</a:t>
+              <a:t>Code Implementation: 401 Session Interceptor (Client)</a:t>
             </a:r>
           </a:p>
         </p:txBody>
       </p:sp>
-      <p:pic>
-        <p:nvPicPr>
-          <p:cNvPr id="5" name="Picture 4" descr="login.jpg"/>
-          <p:cNvPicPr>
-            <a:picLocks noChangeAspect="1"/>
-          </p:cNvPicPr>
+      <p:sp>
+        <p:nvSpPr>
+          <p:cNvPr id="5" name="TextBox 4"/>
+          <p:cNvSpPr txBox="1"/>
           <p:nvPr/>
-        </p:nvPicPr>
-        <p:blipFill>
-          <a:blip r:embed="rId2"/>
-          <a:stretch>
-            <a:fillRect/>
-          </a:stretch>
-        </p:blipFill>
+        </p:nvSpPr>
         <p:spPr>
           <a:xfrm>
-            <a:off x="914400" y="1371600"/>
-            <a:ext cx="7315200" cy="4114800"/>
+            <a:off x="457200" y="1097280"/>
+            <a:ext cx="8229600" cy="731520"/>
           </a:xfrm>
           <a:prstGeom prst="rect">
             <a:avLst/>
           </a:prstGeom>
+          <a:noFill/>
         </p:spPr>
-      </p:pic>
+        <p:txBody>
+          <a:bodyPr wrap="none">
+            <a:spAutoFit/>
+          </a:bodyPr>
+          <a:lstStyle/>
+          <a:p>
+            <a:pPr>
+              <a:defRPr sz="1200" i="1">
+                <a:solidFill>
+                  <a:srgbClr val="2D2724"/>
+                </a:solidFill>
+              </a:defRPr>
+            </a:pPr>
+            <a:r>
+              <a:t>Detects database resets and safely redirects stale sessions back to login</a:t>
+            </a:r>
+          </a:p>
+        </p:txBody>
+      </p:sp>
+      <p:sp>
+        <p:nvSpPr>
+          <p:cNvPr id="6" name="TextBox 5"/>
+          <p:cNvSpPr txBox="1"/>
+          <p:nvPr/>
+        </p:nvSpPr>
+        <p:spPr>
+          <a:xfrm>
+            <a:off x="457200" y="1828800"/>
+            <a:ext cx="8229600" cy="4114800"/>
+          </a:xfrm>
+          <a:prstGeom prst="rect">
+            <a:avLst/>
+          </a:prstGeom>
+          <a:noFill/>
+        </p:spPr>
+        <p:txBody>
+          <a:bodyPr wrap="square">
+            <a:spAutoFit/>
+          </a:bodyPr>
+          <a:lstStyle/>
+          <a:p>
+            <a:pPr>
+              <a:defRPr sz="1050">
+                <a:solidFill>
+                  <a:srgbClr val="2D2724"/>
+                </a:solidFill>
+                <a:latin typeface="Consolas"/>
+              </a:defRPr>
+            </a:pPr>
+            <a:r>
+              <a:t>// frontend/src/api/axios.js</a:t>
+            </a:r>
+            <a:br/>
+            <a:r>
+              <a:t>api.interceptors.response.use(</a:t>
+            </a:r>
+            <a:br/>
+            <a:r>
+              <a:t>  (response) =&gt; response,</a:t>
+            </a:r>
+            <a:br/>
+            <a:r>
+              <a:t>  (error) =&gt; {</a:t>
+            </a:r>
+            <a:br/>
+            <a:r>
+              <a:t>    if (error.response &amp;&amp; error.response.status === 401) {</a:t>
+            </a:r>
+            <a:br/>
+            <a:r>
+              <a:t>      // Dispatch global logout event when session is stale (e.g. database re-seeded)</a:t>
+            </a:r>
+            <a:br/>
+            <a:r>
+              <a:t>      window.dispatchEvent(new CustomEvent('shopez-logout'));</a:t>
+            </a:r>
+            <a:br/>
+            <a:r>
+              <a:t>    }</a:t>
+            </a:r>
+            <a:br/>
+            <a:r>
+              <a:t>    return Promise.reject(error);</a:t>
+            </a:r>
+            <a:br/>
+            <a:r>
+              <a:t>  }</a:t>
+            </a:r>
+            <a:br/>
+            <a:r>
+              <a:t>);</a:t>
+            </a:r>
+          </a:p>
+        </p:txBody>
+      </p:sp>
+      <p:sp>
+        <p:nvSpPr>
+          <p:cNvPr id="7" name="TextBox 6"/>
+          <p:cNvSpPr txBox="1"/>
+          <p:nvPr/>
+        </p:nvSpPr>
+        <p:spPr>
+          <a:xfrm>
+            <a:off x="457200" y="6217920"/>
+            <a:ext cx="8229600" cy="457200"/>
+          </a:xfrm>
+          <a:prstGeom prst="rect">
+            <a:avLst/>
+          </a:prstGeom>
+          <a:noFill/>
+        </p:spPr>
+        <p:txBody>
+          <a:bodyPr wrap="none">
+            <a:spAutoFit/>
+          </a:bodyPr>
+          <a:lstStyle/>
+          <a:p>
+            <a:pPr>
+              <a:defRPr sz="900" i="1">
+                <a:solidFill>
+                  <a:srgbClr val="72625B"/>
+                </a:solidFill>
+              </a:defRPr>
+            </a:pPr>
+            <a:r>
+              <a:t>Department of Computer Science and Engineering | Implementation Code</a:t>
+            </a:r>
+          </a:p>
+        </p:txBody>
+      </p:sp>
     </p:spTree>
   </p:cSld>
   <p:clrMapOvr>
@@ -12044,42 +12286,160 @@
           <a:lstStyle/>
           <a:p>
             <a:pPr>
-              <a:defRPr sz="2400" b="1">
+              <a:defRPr sz="2200" b="1">
                 <a:solidFill>
                   <a:srgbClr val="C05C46"/>
                 </a:solidFill>
               </a:defRPr>
             </a:pPr>
             <a:r>
-              <a:t>Results: Seller Dashboard Metrics</a:t>
+              <a:t>Code Implementation: 3D Flip Payment Card (UI)</a:t>
             </a:r>
           </a:p>
         </p:txBody>
       </p:sp>
-      <p:pic>
-        <p:nvPicPr>
-          <p:cNvPr id="5" name="Picture 4" descr="seller_dashboard.jpg"/>
-          <p:cNvPicPr>
-            <a:picLocks noChangeAspect="1"/>
-          </p:cNvPicPr>
+      <p:sp>
+        <p:nvSpPr>
+          <p:cNvPr id="5" name="TextBox 4"/>
+          <p:cNvSpPr txBox="1"/>
           <p:nvPr/>
-        </p:nvPicPr>
-        <p:blipFill>
-          <a:blip r:embed="rId2"/>
-          <a:stretch>
-            <a:fillRect/>
-          </a:stretch>
-        </p:blipFill>
+        </p:nvSpPr>
         <p:spPr>
           <a:xfrm>
-            <a:off x="914400" y="1371600"/>
-            <a:ext cx="7315200" cy="4114800"/>
+            <a:off x="457200" y="1097280"/>
+            <a:ext cx="8229600" cy="731520"/>
           </a:xfrm>
           <a:prstGeom prst="rect">
             <a:avLst/>
           </a:prstGeom>
+          <a:noFill/>
         </p:spPr>
-      </p:pic>
+        <p:txBody>
+          <a:bodyPr wrap="none">
+            <a:spAutoFit/>
+          </a:bodyPr>
+          <a:lstStyle/>
+          <a:p>
+            <a:pPr>
+              <a:defRPr sz="1200" i="1">
+                <a:solidFill>
+                  <a:srgbClr val="2D2724"/>
+                </a:solidFill>
+              </a:defRPr>
+            </a:pPr>
+            <a:r>
+              <a:t>React stateful triggers flip the virtual card during focus transitions on checkout</a:t>
+            </a:r>
+          </a:p>
+        </p:txBody>
+      </p:sp>
+      <p:sp>
+        <p:nvSpPr>
+          <p:cNvPr id="6" name="TextBox 5"/>
+          <p:cNvSpPr txBox="1"/>
+          <p:nvPr/>
+        </p:nvSpPr>
+        <p:spPr>
+          <a:xfrm>
+            <a:off x="457200" y="1828800"/>
+            <a:ext cx="8229600" cy="4114800"/>
+          </a:xfrm>
+          <a:prstGeom prst="rect">
+            <a:avLst/>
+          </a:prstGeom>
+          <a:noFill/>
+        </p:spPr>
+        <p:txBody>
+          <a:bodyPr wrap="square">
+            <a:spAutoFit/>
+          </a:bodyPr>
+          <a:lstStyle/>
+          <a:p>
+            <a:pPr>
+              <a:defRPr sz="1050">
+                <a:solidFill>
+                  <a:srgbClr val="2D2724"/>
+                </a:solidFill>
+                <a:latin typeface="Consolas"/>
+              </a:defRPr>
+            </a:pPr>
+            <a:r>
+              <a:t>// frontend/src/pages/Checkout.js</a:t>
+            </a:r>
+            <a:br/>
+            <a:r>
+              <a:t>// 3D Perspective Card Component Flipping Logic:</a:t>
+            </a:r>
+            <a:br/>
+            <a:r>
+              <a:t>&lt;div className="flip-card-container"&gt;</a:t>
+            </a:r>
+            <a:br/>
+            <a:r>
+              <a:t>  &lt;div className={`flip-card-inner ${cardFlipped ? 'flipped' : ''}`}&gt;</a:t>
+            </a:r>
+            <a:br/>
+            <a:r>
+              <a:t>    {/* Front Layout showing Name, Number, Expiry */}</a:t>
+            </a:r>
+            <a:br/>
+            <a:r>
+              <a:t>    &lt;div className="card-front"&gt;...&lt;/div&gt;</a:t>
+            </a:r>
+            <a:br/>
+            <a:r>
+              <a:t>    {/* Back Layout showing Signature Box and CVV */}</a:t>
+            </a:r>
+            <a:br/>
+            <a:r>
+              <a:t>    &lt;div className="card-back"&gt;...&lt;/div&gt;</a:t>
+            </a:r>
+            <a:br/>
+            <a:r>
+              <a:t>  &lt;/div&gt;</a:t>
+            </a:r>
+            <a:br/>
+            <a:r>
+              <a:t>&lt;/div&gt;</a:t>
+            </a:r>
+          </a:p>
+        </p:txBody>
+      </p:sp>
+      <p:sp>
+        <p:nvSpPr>
+          <p:cNvPr id="7" name="TextBox 6"/>
+          <p:cNvSpPr txBox="1"/>
+          <p:nvPr/>
+        </p:nvSpPr>
+        <p:spPr>
+          <a:xfrm>
+            <a:off x="457200" y="6217920"/>
+            <a:ext cx="8229600" cy="457200"/>
+          </a:xfrm>
+          <a:prstGeom prst="rect">
+            <a:avLst/>
+          </a:prstGeom>
+          <a:noFill/>
+        </p:spPr>
+        <p:txBody>
+          <a:bodyPr wrap="none">
+            <a:spAutoFit/>
+          </a:bodyPr>
+          <a:lstStyle/>
+          <a:p>
+            <a:pPr>
+              <a:defRPr sz="900" i="1">
+                <a:solidFill>
+                  <a:srgbClr val="72625B"/>
+                </a:solidFill>
+              </a:defRPr>
+            </a:pPr>
+            <a:r>
+              <a:t>Department of Computer Science and Engineering | Implementation Code</a:t>
+            </a:r>
+          </a:p>
+        </p:txBody>
+      </p:sp>
     </p:spTree>
   </p:cSld>
   <p:clrMapOvr>
@@ -12155,86 +12515,42 @@
           <a:lstStyle/>
           <a:p>
             <a:pPr>
-              <a:defRPr sz="2400" b="1">
+              <a:defRPr sz="2200" b="1">
                 <a:solidFill>
                   <a:srgbClr val="C05C46"/>
                 </a:solidFill>
               </a:defRPr>
             </a:pPr>
             <a:r>
-              <a:t>Advantages &amp; Limitations</a:t>
+              <a:t>Output Screen: E-Commerce Product Catalog</a:t>
             </a:r>
           </a:p>
         </p:txBody>
       </p:sp>
-      <p:sp>
-        <p:nvSpPr>
-          <p:cNvPr id="5" name="TextBox 4"/>
-          <p:cNvSpPr txBox="1"/>
+      <p:pic>
+        <p:nvPicPr>
+          <p:cNvPr id="5" name="Picture 4" descr="Screenshot (16).png"/>
+          <p:cNvPicPr>
+            <a:picLocks noChangeAspect="1"/>
+          </p:cNvPicPr>
           <p:nvPr/>
-        </p:nvSpPr>
+        </p:nvPicPr>
+        <p:blipFill>
+          <a:blip r:embed="rId2"/>
+          <a:stretch>
+            <a:fillRect/>
+          </a:stretch>
+        </p:blipFill>
         <p:spPr>
           <a:xfrm>
-            <a:off x="457200" y="1371600"/>
-            <a:ext cx="8229600" cy="4572000"/>
+            <a:off x="914400" y="1371600"/>
+            <a:ext cx="7315200" cy="4389120"/>
           </a:xfrm>
           <a:prstGeom prst="rect">
             <a:avLst/>
           </a:prstGeom>
-          <a:noFill/>
         </p:spPr>
-        <p:txBody>
-          <a:bodyPr wrap="square">
-            <a:spAutoFit/>
-          </a:bodyPr>
-          <a:lstStyle/>
-          <a:p>
-            <a:pPr>
-              <a:spcAft>
-                <a:spcPts val="1000"/>
-              </a:spcAft>
-              <a:defRPr sz="1400">
-                <a:solidFill>
-                  <a:srgbClr val="2D2724"/>
-                </a:solidFill>
-              </a:defRPr>
-            </a:pPr>
-            <a:r>
-              <a:t>• Advantages: Engaging layout style increases user session durations; robust stale session handlers prevent crashes.</a:t>
-            </a:r>
-          </a:p>
-          <a:p>
-            <a:pPr>
-              <a:spcAft>
-                <a:spcPts val="1000"/>
-              </a:spcAft>
-              <a:defRPr sz="1400">
-                <a:solidFill>
-                  <a:srgbClr val="2D2724"/>
-                </a:solidFill>
-              </a:defRPr>
-            </a:pPr>
-            <a:r>
-              <a:t>• Advantages: Decoupled codebase controllers make features expansion clean and easy.</a:t>
-            </a:r>
-          </a:p>
-          <a:p>
-            <a:pPr>
-              <a:spcAft>
-                <a:spcPts val="1000"/>
-              </a:spcAft>
-              <a:defRPr sz="1400">
-                <a:solidFill>
-                  <a:srgbClr val="2D2724"/>
-                </a:solidFill>
-              </a:defRPr>
-            </a:pPr>
-            <a:r>
-              <a:t>• Limitations: Local MongoDB storage configuration; does not have multiple billing currency conversion supports.</a:t>
-            </a:r>
-          </a:p>
-        </p:txBody>
-      </p:sp>
+      </p:pic>
       <p:sp>
         <p:nvSpPr>
           <p:cNvPr id="6" name="TextBox 5"/>
@@ -12265,7 +12581,7 @@
               </a:defRPr>
             </a:pPr>
             <a:r>
-              <a:t>Department of Computer Science and Engineering | ShopEZ Project</a:t>
+              <a:t>Department of Computer Science and Engineering | Project Output Screens</a:t>
             </a:r>
           </a:p>
         </p:txBody>
@@ -12345,6 +12661,634 @@
           <a:lstStyle/>
           <a:p>
             <a:pPr>
+              <a:defRPr sz="2200" b="1">
+                <a:solidFill>
+                  <a:srgbClr val="C05C46"/>
+                </a:solidFill>
+              </a:defRPr>
+            </a:pPr>
+            <a:r>
+              <a:t>Output Screen: Detailed Specs &amp; User Reviews</a:t>
+            </a:r>
+          </a:p>
+        </p:txBody>
+      </p:sp>
+      <p:pic>
+        <p:nvPicPr>
+          <p:cNvPr id="5" name="Picture 4" descr="Screenshot (17).png"/>
+          <p:cNvPicPr>
+            <a:picLocks noChangeAspect="1"/>
+          </p:cNvPicPr>
+          <p:nvPr/>
+        </p:nvPicPr>
+        <p:blipFill>
+          <a:blip r:embed="rId2"/>
+          <a:stretch>
+            <a:fillRect/>
+          </a:stretch>
+        </p:blipFill>
+        <p:spPr>
+          <a:xfrm>
+            <a:off x="914400" y="1371600"/>
+            <a:ext cx="7315200" cy="4389120"/>
+          </a:xfrm>
+          <a:prstGeom prst="rect">
+            <a:avLst/>
+          </a:prstGeom>
+        </p:spPr>
+      </p:pic>
+      <p:sp>
+        <p:nvSpPr>
+          <p:cNvPr id="6" name="TextBox 5"/>
+          <p:cNvSpPr txBox="1"/>
+          <p:nvPr/>
+        </p:nvSpPr>
+        <p:spPr>
+          <a:xfrm>
+            <a:off x="457200" y="6217920"/>
+            <a:ext cx="8229600" cy="457200"/>
+          </a:xfrm>
+          <a:prstGeom prst="rect">
+            <a:avLst/>
+          </a:prstGeom>
+          <a:noFill/>
+        </p:spPr>
+        <p:txBody>
+          <a:bodyPr wrap="none">
+            <a:spAutoFit/>
+          </a:bodyPr>
+          <a:lstStyle/>
+          <a:p>
+            <a:pPr>
+              <a:defRPr sz="900" i="1">
+                <a:solidFill>
+                  <a:srgbClr val="72625B"/>
+                </a:solidFill>
+              </a:defRPr>
+            </a:pPr>
+            <a:r>
+              <a:t>Department of Computer Science and Engineering | Project Output Screens</a:t>
+            </a:r>
+          </a:p>
+        </p:txBody>
+      </p:sp>
+    </p:spTree>
+  </p:cSld>
+  <p:clrMapOvr>
+    <a:masterClrMapping/>
+  </p:clrMapOvr>
+</p:sld>
+</file>
+
+<file path=ppt/slides/slide15.xml><?xml version="1.0" encoding="utf-8"?>
+<p:sld xmlns:a="http://schemas.openxmlformats.org/drawingml/2006/main" xmlns:p="http://schemas.openxmlformats.org/presentationml/2006/main" xmlns:r="http://schemas.openxmlformats.org/officeDocument/2006/relationships">
+  <p:cSld>
+    <p:spTree>
+      <p:nvGrpSpPr>
+        <p:cNvPr id="1" name=""/>
+        <p:cNvGrpSpPr/>
+        <p:nvPr/>
+      </p:nvGrpSpPr>
+      <p:grpSpPr/>
+      <p:sp>
+        <p:nvSpPr>
+          <p:cNvPr id="2" name="Title 1"/>
+          <p:cNvSpPr>
+            <a:spLocks noGrp="1"/>
+          </p:cNvSpPr>
+          <p:nvPr>
+            <p:ph type="title"/>
+          </p:nvPr>
+        </p:nvSpPr>
+        <p:spPr/>
+        <p:txBody>
+          <a:bodyPr/>
+          <a:lstStyle/>
+          <a:p/>
+        </p:txBody>
+      </p:sp>
+      <p:sp>
+        <p:nvSpPr>
+          <p:cNvPr id="3" name="Text Placeholder 2"/>
+          <p:cNvSpPr>
+            <a:spLocks noGrp="1"/>
+          </p:cNvSpPr>
+          <p:nvPr>
+            <p:ph type="body" idx="1"/>
+          </p:nvPr>
+        </p:nvSpPr>
+        <p:spPr/>
+        <p:txBody>
+          <a:bodyPr/>
+          <a:lstStyle/>
+          <a:p/>
+        </p:txBody>
+      </p:sp>
+      <p:sp>
+        <p:nvSpPr>
+          <p:cNvPr id="4" name="TextBox 3"/>
+          <p:cNvSpPr txBox="1"/>
+          <p:nvPr/>
+        </p:nvSpPr>
+        <p:spPr>
+          <a:xfrm>
+            <a:off x="457200" y="457200"/>
+            <a:ext cx="8229600" cy="914400"/>
+          </a:xfrm>
+          <a:prstGeom prst="rect">
+            <a:avLst/>
+          </a:prstGeom>
+          <a:noFill/>
+        </p:spPr>
+        <p:txBody>
+          <a:bodyPr wrap="none">
+            <a:spAutoFit/>
+          </a:bodyPr>
+          <a:lstStyle/>
+          <a:p>
+            <a:pPr>
+              <a:defRPr sz="2200" b="1">
+                <a:solidFill>
+                  <a:srgbClr val="C05C46"/>
+                </a:solidFill>
+              </a:defRPr>
+            </a:pPr>
+            <a:r>
+              <a:t>Output Screen: Interactive Flipping Credit Card Form</a:t>
+            </a:r>
+          </a:p>
+        </p:txBody>
+      </p:sp>
+      <p:pic>
+        <p:nvPicPr>
+          <p:cNvPr id="5" name="Picture 4" descr="Screenshot (18).png"/>
+          <p:cNvPicPr>
+            <a:picLocks noChangeAspect="1"/>
+          </p:cNvPicPr>
+          <p:nvPr/>
+        </p:nvPicPr>
+        <p:blipFill>
+          <a:blip r:embed="rId2"/>
+          <a:stretch>
+            <a:fillRect/>
+          </a:stretch>
+        </p:blipFill>
+        <p:spPr>
+          <a:xfrm>
+            <a:off x="914400" y="1371600"/>
+            <a:ext cx="7315200" cy="4389120"/>
+          </a:xfrm>
+          <a:prstGeom prst="rect">
+            <a:avLst/>
+          </a:prstGeom>
+        </p:spPr>
+      </p:pic>
+      <p:sp>
+        <p:nvSpPr>
+          <p:cNvPr id="6" name="TextBox 5"/>
+          <p:cNvSpPr txBox="1"/>
+          <p:nvPr/>
+        </p:nvSpPr>
+        <p:spPr>
+          <a:xfrm>
+            <a:off x="457200" y="6217920"/>
+            <a:ext cx="8229600" cy="457200"/>
+          </a:xfrm>
+          <a:prstGeom prst="rect">
+            <a:avLst/>
+          </a:prstGeom>
+          <a:noFill/>
+        </p:spPr>
+        <p:txBody>
+          <a:bodyPr wrap="none">
+            <a:spAutoFit/>
+          </a:bodyPr>
+          <a:lstStyle/>
+          <a:p>
+            <a:pPr>
+              <a:defRPr sz="900" i="1">
+                <a:solidFill>
+                  <a:srgbClr val="72625B"/>
+                </a:solidFill>
+              </a:defRPr>
+            </a:pPr>
+            <a:r>
+              <a:t>Department of Computer Science and Engineering | Project Output Screens</a:t>
+            </a:r>
+          </a:p>
+        </p:txBody>
+      </p:sp>
+    </p:spTree>
+  </p:cSld>
+  <p:clrMapOvr>
+    <a:masterClrMapping/>
+  </p:clrMapOvr>
+</p:sld>
+</file>
+
+<file path=ppt/slides/slide16.xml><?xml version="1.0" encoding="utf-8"?>
+<p:sld xmlns:a="http://schemas.openxmlformats.org/drawingml/2006/main" xmlns:p="http://schemas.openxmlformats.org/presentationml/2006/main" xmlns:r="http://schemas.openxmlformats.org/officeDocument/2006/relationships">
+  <p:cSld>
+    <p:spTree>
+      <p:nvGrpSpPr>
+        <p:cNvPr id="1" name=""/>
+        <p:cNvGrpSpPr/>
+        <p:nvPr/>
+      </p:nvGrpSpPr>
+      <p:grpSpPr/>
+      <p:sp>
+        <p:nvSpPr>
+          <p:cNvPr id="2" name="Title 1"/>
+          <p:cNvSpPr>
+            <a:spLocks noGrp="1"/>
+          </p:cNvSpPr>
+          <p:nvPr>
+            <p:ph type="title"/>
+          </p:nvPr>
+        </p:nvSpPr>
+        <p:spPr/>
+        <p:txBody>
+          <a:bodyPr/>
+          <a:lstStyle/>
+          <a:p/>
+        </p:txBody>
+      </p:sp>
+      <p:sp>
+        <p:nvSpPr>
+          <p:cNvPr id="3" name="Text Placeholder 2"/>
+          <p:cNvSpPr>
+            <a:spLocks noGrp="1"/>
+          </p:cNvSpPr>
+          <p:nvPr>
+            <p:ph type="body" idx="1"/>
+          </p:nvPr>
+        </p:nvSpPr>
+        <p:spPr/>
+        <p:txBody>
+          <a:bodyPr/>
+          <a:lstStyle/>
+          <a:p/>
+        </p:txBody>
+      </p:sp>
+      <p:sp>
+        <p:nvSpPr>
+          <p:cNvPr id="4" name="TextBox 3"/>
+          <p:cNvSpPr txBox="1"/>
+          <p:nvPr/>
+        </p:nvSpPr>
+        <p:spPr>
+          <a:xfrm>
+            <a:off x="457200" y="457200"/>
+            <a:ext cx="8229600" cy="914400"/>
+          </a:xfrm>
+          <a:prstGeom prst="rect">
+            <a:avLst/>
+          </a:prstGeom>
+          <a:noFill/>
+        </p:spPr>
+        <p:txBody>
+          <a:bodyPr wrap="none">
+            <a:spAutoFit/>
+          </a:bodyPr>
+          <a:lstStyle/>
+          <a:p>
+            <a:pPr>
+              <a:defRPr sz="2200" b="1">
+                <a:solidFill>
+                  <a:srgbClr val="C05C46"/>
+                </a:solidFill>
+              </a:defRPr>
+            </a:pPr>
+            <a:r>
+              <a:t>Output Screen: Seller Operations Dashboard Console</a:t>
+            </a:r>
+          </a:p>
+        </p:txBody>
+      </p:sp>
+      <p:pic>
+        <p:nvPicPr>
+          <p:cNvPr id="5" name="Picture 4" descr="Screenshot (19).png"/>
+          <p:cNvPicPr>
+            <a:picLocks noChangeAspect="1"/>
+          </p:cNvPicPr>
+          <p:nvPr/>
+        </p:nvPicPr>
+        <p:blipFill>
+          <a:blip r:embed="rId2"/>
+          <a:stretch>
+            <a:fillRect/>
+          </a:stretch>
+        </p:blipFill>
+        <p:spPr>
+          <a:xfrm>
+            <a:off x="914400" y="1371600"/>
+            <a:ext cx="7315200" cy="4389120"/>
+          </a:xfrm>
+          <a:prstGeom prst="rect">
+            <a:avLst/>
+          </a:prstGeom>
+        </p:spPr>
+      </p:pic>
+      <p:sp>
+        <p:nvSpPr>
+          <p:cNvPr id="6" name="TextBox 5"/>
+          <p:cNvSpPr txBox="1"/>
+          <p:nvPr/>
+        </p:nvSpPr>
+        <p:spPr>
+          <a:xfrm>
+            <a:off x="457200" y="6217920"/>
+            <a:ext cx="8229600" cy="457200"/>
+          </a:xfrm>
+          <a:prstGeom prst="rect">
+            <a:avLst/>
+          </a:prstGeom>
+          <a:noFill/>
+        </p:spPr>
+        <p:txBody>
+          <a:bodyPr wrap="none">
+            <a:spAutoFit/>
+          </a:bodyPr>
+          <a:lstStyle/>
+          <a:p>
+            <a:pPr>
+              <a:defRPr sz="900" i="1">
+                <a:solidFill>
+                  <a:srgbClr val="72625B"/>
+                </a:solidFill>
+              </a:defRPr>
+            </a:pPr>
+            <a:r>
+              <a:t>Department of Computer Science and Engineering | Project Output Screens</a:t>
+            </a:r>
+          </a:p>
+        </p:txBody>
+      </p:sp>
+    </p:spTree>
+  </p:cSld>
+  <p:clrMapOvr>
+    <a:masterClrMapping/>
+  </p:clrMapOvr>
+</p:sld>
+</file>
+
+<file path=ppt/slides/slide17.xml><?xml version="1.0" encoding="utf-8"?>
+<p:sld xmlns:a="http://schemas.openxmlformats.org/drawingml/2006/main" xmlns:p="http://schemas.openxmlformats.org/presentationml/2006/main" xmlns:r="http://schemas.openxmlformats.org/officeDocument/2006/relationships">
+  <p:cSld>
+    <p:spTree>
+      <p:nvGrpSpPr>
+        <p:cNvPr id="1" name=""/>
+        <p:cNvGrpSpPr/>
+        <p:nvPr/>
+      </p:nvGrpSpPr>
+      <p:grpSpPr/>
+      <p:sp>
+        <p:nvSpPr>
+          <p:cNvPr id="2" name="Title 1"/>
+          <p:cNvSpPr>
+            <a:spLocks noGrp="1"/>
+          </p:cNvSpPr>
+          <p:nvPr>
+            <p:ph type="title"/>
+          </p:nvPr>
+        </p:nvSpPr>
+        <p:spPr/>
+        <p:txBody>
+          <a:bodyPr/>
+          <a:lstStyle/>
+          <a:p/>
+        </p:txBody>
+      </p:sp>
+      <p:sp>
+        <p:nvSpPr>
+          <p:cNvPr id="3" name="Text Placeholder 2"/>
+          <p:cNvSpPr>
+            <a:spLocks noGrp="1"/>
+          </p:cNvSpPr>
+          <p:nvPr>
+            <p:ph type="body" idx="1"/>
+          </p:nvPr>
+        </p:nvSpPr>
+        <p:spPr/>
+        <p:txBody>
+          <a:bodyPr/>
+          <a:lstStyle/>
+          <a:p/>
+        </p:txBody>
+      </p:sp>
+      <p:sp>
+        <p:nvSpPr>
+          <p:cNvPr id="4" name="TextBox 3"/>
+          <p:cNvSpPr txBox="1"/>
+          <p:nvPr/>
+        </p:nvSpPr>
+        <p:spPr>
+          <a:xfrm>
+            <a:off x="457200" y="457200"/>
+            <a:ext cx="8229600" cy="914400"/>
+          </a:xfrm>
+          <a:prstGeom prst="rect">
+            <a:avLst/>
+          </a:prstGeom>
+          <a:noFill/>
+        </p:spPr>
+        <p:txBody>
+          <a:bodyPr wrap="none">
+            <a:spAutoFit/>
+          </a:bodyPr>
+          <a:lstStyle/>
+          <a:p>
+            <a:pPr>
+              <a:defRPr sz="2400" b="1">
+                <a:solidFill>
+                  <a:srgbClr val="C05C46"/>
+                </a:solidFill>
+              </a:defRPr>
+            </a:pPr>
+            <a:r>
+              <a:t>Advantages &amp; Limitations</a:t>
+            </a:r>
+          </a:p>
+        </p:txBody>
+      </p:sp>
+      <p:sp>
+        <p:nvSpPr>
+          <p:cNvPr id="5" name="TextBox 4"/>
+          <p:cNvSpPr txBox="1"/>
+          <p:nvPr/>
+        </p:nvSpPr>
+        <p:spPr>
+          <a:xfrm>
+            <a:off x="457200" y="1371600"/>
+            <a:ext cx="8229600" cy="4572000"/>
+          </a:xfrm>
+          <a:prstGeom prst="rect">
+            <a:avLst/>
+          </a:prstGeom>
+          <a:noFill/>
+        </p:spPr>
+        <p:txBody>
+          <a:bodyPr wrap="square">
+            <a:spAutoFit/>
+          </a:bodyPr>
+          <a:lstStyle/>
+          <a:p>
+            <a:pPr>
+              <a:spcAft>
+                <a:spcPts val="1000"/>
+              </a:spcAft>
+              <a:defRPr sz="1400">
+                <a:solidFill>
+                  <a:srgbClr val="2D2724"/>
+                </a:solidFill>
+              </a:defRPr>
+            </a:pPr>
+            <a:r>
+              <a:t>• Advantages: Engaging layout style increases user session durations; robust stale session handlers prevent crashes.</a:t>
+            </a:r>
+          </a:p>
+          <a:p>
+            <a:pPr>
+              <a:spcAft>
+                <a:spcPts val="1000"/>
+              </a:spcAft>
+              <a:defRPr sz="1400">
+                <a:solidFill>
+                  <a:srgbClr val="2D2724"/>
+                </a:solidFill>
+              </a:defRPr>
+            </a:pPr>
+            <a:r>
+              <a:t>• Advantages: Decoupled codebase controllers make features expansion clean and easy.</a:t>
+            </a:r>
+          </a:p>
+          <a:p>
+            <a:pPr>
+              <a:spcAft>
+                <a:spcPts val="1000"/>
+              </a:spcAft>
+              <a:defRPr sz="1400">
+                <a:solidFill>
+                  <a:srgbClr val="2D2724"/>
+                </a:solidFill>
+              </a:defRPr>
+            </a:pPr>
+            <a:r>
+              <a:t>• Limitations: Local MongoDB storage configuration; does not have multiple billing currency conversion supports.</a:t>
+            </a:r>
+          </a:p>
+        </p:txBody>
+      </p:sp>
+      <p:sp>
+        <p:nvSpPr>
+          <p:cNvPr id="6" name="TextBox 5"/>
+          <p:cNvSpPr txBox="1"/>
+          <p:nvPr/>
+        </p:nvSpPr>
+        <p:spPr>
+          <a:xfrm>
+            <a:off x="457200" y="6217920"/>
+            <a:ext cx="8229600" cy="457200"/>
+          </a:xfrm>
+          <a:prstGeom prst="rect">
+            <a:avLst/>
+          </a:prstGeom>
+          <a:noFill/>
+        </p:spPr>
+        <p:txBody>
+          <a:bodyPr wrap="none">
+            <a:spAutoFit/>
+          </a:bodyPr>
+          <a:lstStyle/>
+          <a:p>
+            <a:pPr>
+              <a:defRPr sz="900" i="1">
+                <a:solidFill>
+                  <a:srgbClr val="72625B"/>
+                </a:solidFill>
+              </a:defRPr>
+            </a:pPr>
+            <a:r>
+              <a:t>Department of Computer Science and Engineering | ShopEZ Project</a:t>
+            </a:r>
+          </a:p>
+        </p:txBody>
+      </p:sp>
+    </p:spTree>
+  </p:cSld>
+  <p:clrMapOvr>
+    <a:masterClrMapping/>
+  </p:clrMapOvr>
+</p:sld>
+</file>
+
+<file path=ppt/slides/slide18.xml><?xml version="1.0" encoding="utf-8"?>
+<p:sld xmlns:a="http://schemas.openxmlformats.org/drawingml/2006/main" xmlns:p="http://schemas.openxmlformats.org/presentationml/2006/main" xmlns:r="http://schemas.openxmlformats.org/officeDocument/2006/relationships">
+  <p:cSld>
+    <p:spTree>
+      <p:nvGrpSpPr>
+        <p:cNvPr id="1" name=""/>
+        <p:cNvGrpSpPr/>
+        <p:nvPr/>
+      </p:nvGrpSpPr>
+      <p:grpSpPr/>
+      <p:sp>
+        <p:nvSpPr>
+          <p:cNvPr id="2" name="Title 1"/>
+          <p:cNvSpPr>
+            <a:spLocks noGrp="1"/>
+          </p:cNvSpPr>
+          <p:nvPr>
+            <p:ph type="title"/>
+          </p:nvPr>
+        </p:nvSpPr>
+        <p:spPr/>
+        <p:txBody>
+          <a:bodyPr/>
+          <a:lstStyle/>
+          <a:p/>
+        </p:txBody>
+      </p:sp>
+      <p:sp>
+        <p:nvSpPr>
+          <p:cNvPr id="3" name="Text Placeholder 2"/>
+          <p:cNvSpPr>
+            <a:spLocks noGrp="1"/>
+          </p:cNvSpPr>
+          <p:nvPr>
+            <p:ph type="body" idx="1"/>
+          </p:nvPr>
+        </p:nvSpPr>
+        <p:spPr/>
+        <p:txBody>
+          <a:bodyPr/>
+          <a:lstStyle/>
+          <a:p/>
+        </p:txBody>
+      </p:sp>
+      <p:sp>
+        <p:nvSpPr>
+          <p:cNvPr id="4" name="TextBox 3"/>
+          <p:cNvSpPr txBox="1"/>
+          <p:nvPr/>
+        </p:nvSpPr>
+        <p:spPr>
+          <a:xfrm>
+            <a:off x="457200" y="457200"/>
+            <a:ext cx="8229600" cy="914400"/>
+          </a:xfrm>
+          <a:prstGeom prst="rect">
+            <a:avLst/>
+          </a:prstGeom>
+          <a:noFill/>
+        </p:spPr>
+        <p:txBody>
+          <a:bodyPr wrap="none">
+            <a:spAutoFit/>
+          </a:bodyPr>
+          <a:lstStyle/>
+          <a:p>
+            <a:pPr>
               <a:defRPr sz="2400" b="1">
                 <a:solidFill>
                   <a:srgbClr val="C05C46"/>
@@ -12468,7 +13412,7 @@
 </p:sld>
 </file>
 
-<file path=ppt/slides/slide15.xml><?xml version="1.0" encoding="utf-8"?>
+<file path=ppt/slides/slide19.xml><?xml version="1.0" encoding="utf-8"?>
 <p:sld xmlns:a="http://schemas.openxmlformats.org/drawingml/2006/main" xmlns:p="http://schemas.openxmlformats.org/presentationml/2006/main" xmlns:r="http://schemas.openxmlformats.org/officeDocument/2006/relationships">
   <p:cSld>
     <p:spTree>

</xml_diff>